<commit_message>
Freebuff: In read me i need - all of these , team name - six seven...
</commit_message>
<xml_diff>
--- a/docs/presentation.pptx
+++ b/docs/presentation.pptx
@@ -3267,7 +3267,7 @@
                 </a:solidFill>
                 <a:latin typeface="Arial"/>
               </a:rPr>
-              <a:t>[TEAM NAME]  ·  [COLLEGE]  ·  [INCUBATOR]</a:t>
+              <a:t>six seven  ·  [COLLEGE]  ·  [INCUBATOR]</a:t>
             </a:r>
           </a:p>
         </p:txBody>
@@ -8587,7 +8587,7 @@
                 </a:solidFill>
                 <a:latin typeface="Arial"/>
               </a:rPr>
-              <a:t>[TEAM NAME]  ·  [EMAIL]  ·  Demo video: [LINK]  ·  Code: [REPOSITORY]</a:t>
+              <a:t>six seven  ·  [EMAIL]  ·  Demo video: [LINK]  ·  Code: [REPOSITORY]</a:t>
             </a:r>
           </a:p>
         </p:txBody>

</xml_diff>

<commit_message>
Freebuff: Remove anywhere u left space or prompt for me to change l...
</commit_message>
<xml_diff>
--- a/docs/presentation.pptx
+++ b/docs/presentation.pptx
@@ -3267,7 +3267,7 @@
                 </a:solidFill>
                 <a:latin typeface="Arial"/>
               </a:rPr>
-              <a:t>six seven  ·  [COLLEGE]  ·  [INCUBATOR]</a:t>
+              <a:t>six seven  ·  IGDTUW</a:t>
             </a:r>
           </a:p>
         </p:txBody>
@@ -7751,7 +7751,7 @@
                 </a:solidFill>
                 <a:latin typeface="Arial"/>
               </a:rPr>
-              <a:t>101 million people with diabetes in India. 136 million with prediabetes. [CITE]</a:t>
+              <a:t>101 million people with diabetes in India. 136 million with prediabetes.</a:t>
             </a:r>
           </a:p>
         </p:txBody>
@@ -7946,7 +7946,7 @@
                 </a:solidFill>
                 <a:latin typeface="Arial"/>
               </a:rPr>
-              <a:t>ICMR-INDIAB, 2023. Citation to be completed before submission.</a:t>
+              <a:t>Source: Anjana et al., Lancet Diabetes &amp; Endocrinology, 2023 (ICMR-INDIAB national study).</a:t>
             </a:r>
           </a:p>
         </p:txBody>
@@ -8587,7 +8587,7 @@
                 </a:solidFill>
                 <a:latin typeface="Arial"/>
               </a:rPr>
-              <a:t>six seven  ·  [EMAIL]  ·  Demo video: [LINK]  ·  Code: [REPOSITORY]</a:t>
+              <a:t>six seven  ·  glucotwin.freebuff.app  ·  youtu.be/K4raAnGqGx0</a:t>
             </a:r>
           </a:p>
         </p:txBody>

</xml_diff>

<commit_message>
Freebuff: Deck text: six seven · IGDTUW on slide 1, The source line...
</commit_message>
<xml_diff>
--- a/docs/presentation.pptx
+++ b/docs/presentation.pptx
@@ -3267,7 +3267,7 @@
                 </a:solidFill>
                 <a:latin typeface="Arial"/>
               </a:rPr>
-              <a:t>six seven  ·  IGDTUW</a:t>
+              <a:t>six seven</a:t>
             </a:r>
           </a:p>
         </p:txBody>
@@ -7946,7 +7946,7 @@
                 </a:solidFill>
                 <a:latin typeface="Arial"/>
               </a:rPr>
-              <a:t>Source: Anjana et al., Lancet Diabetes &amp; Endocrinology, 2023 (ICMR-INDIAB national study).</a:t>
+              <a:t>Anjana et al., Lancet Diabetes &amp; Endocrinology, 2023. ICMR-INDIAB national study.</a:t>
             </a:r>
           </a:p>
         </p:txBody>
@@ -8587,7 +8587,7 @@
                 </a:solidFill>
                 <a:latin typeface="Arial"/>
               </a:rPr>
-              <a:t>six seven  ·  glucotwin.freebuff.app  ·  youtu.be/K4raAnGqGx0</a:t>
+              <a:t>Demo video: https://youtu.be/K4raAnGqGx0   ·   Prototype: https://glucotwin.freebuff.app/</a:t>
             </a:r>
           </a:p>
         </p:txBody>

</xml_diff>